<commit_message>
Faithful rebuild: bold legend equals signs, full table frame height, footer moved up
Co-Authored-By: Claude Opus 5.5 <noreply@anthropic.com>
Claude-Session: https://claude.ai/code/session_01QhAcegZCA84C1dHz9XeXfw
</commit_message>
<xml_diff>
--- a/slides/figure1/faithful.pptx
+++ b/slides/figure1/faithful.pptx
@@ -1956,7 +1956,7 @@
         </p:nvGraphicFramePr>
         <p:xfrm>
           <a:off x="3838956" y="1064958"/>
-          <a:ext cx="2453640" cy="914400"/>
+          <a:ext cx="2453640" cy="4433647"/>
         </p:xfrm>
         <a:graphic>
           <a:graphicData uri="http://schemas.openxmlformats.org/drawingml/2006/table">
@@ -4866,7 +4866,35 @@
                 <a:ea typeface="Arial" pitchFamily="34" charset="-122"/>
                 <a:cs typeface="Arial" pitchFamily="34" charset="-120"/>
               </a:rPr>
-              <a:t>DME = development, modernization, and enhancement</a:t>
+              <a:t>DME </a:t>
+            </a:r>
+            <a:pPr indent="0" marL="0">
+              <a:buNone/>
+            </a:pPr>
+            <a:r>
+              <a:rPr lang="en-US" sz="700" b="1" dirty="0">
+                <a:solidFill>
+                  <a:srgbClr val="000000"/>
+                </a:solidFill>
+                <a:latin typeface="Arial" pitchFamily="34" charset="0"/>
+                <a:ea typeface="Arial" pitchFamily="34" charset="-122"/>
+                <a:cs typeface="Arial" pitchFamily="34" charset="-120"/>
+              </a:rPr>
+              <a:t>=</a:t>
+            </a:r>
+            <a:pPr indent="0" marL="0">
+              <a:buNone/>
+            </a:pPr>
+            <a:r>
+              <a:rPr lang="en-US" sz="700" dirty="0">
+                <a:solidFill>
+                  <a:srgbClr val="000000"/>
+                </a:solidFill>
+                <a:latin typeface="Arial" pitchFamily="34" charset="0"/>
+                <a:ea typeface="Arial" pitchFamily="34" charset="-122"/>
+                <a:cs typeface="Arial" pitchFamily="34" charset="-120"/>
+              </a:rPr>
+              <a:t> development, modernization, and enhancement</a:t>
             </a:r>
             <a:endParaRPr lang="en-US" sz="700" dirty="0"/>
           </a:p>
@@ -4930,7 +4958,35 @@
                 <a:ea typeface="Arial" pitchFamily="34" charset="-122"/>
                 <a:cs typeface="Arial" pitchFamily="34" charset="-120"/>
               </a:rPr>
-              <a:t>O&amp;M = operations and maintenance</a:t>
+              <a:t>O&amp;M </a:t>
+            </a:r>
+            <a:pPr indent="0" marL="0">
+              <a:buNone/>
+            </a:pPr>
+            <a:r>
+              <a:rPr lang="en-US" sz="700" b="1" dirty="0">
+                <a:solidFill>
+                  <a:srgbClr val="000000"/>
+                </a:solidFill>
+                <a:latin typeface="Arial" pitchFamily="34" charset="0"/>
+                <a:ea typeface="Arial" pitchFamily="34" charset="-122"/>
+                <a:cs typeface="Arial" pitchFamily="34" charset="-120"/>
+              </a:rPr>
+              <a:t>=</a:t>
+            </a:r>
+            <a:pPr indent="0" marL="0">
+              <a:buNone/>
+            </a:pPr>
+            <a:r>
+              <a:rPr lang="en-US" sz="700" dirty="0">
+                <a:solidFill>
+                  <a:srgbClr val="000000"/>
+                </a:solidFill>
+                <a:latin typeface="Arial" pitchFamily="34" charset="0"/>
+                <a:ea typeface="Arial" pitchFamily="34" charset="-122"/>
+                <a:cs typeface="Arial" pitchFamily="34" charset="-120"/>
+              </a:rPr>
+              <a:t> operations and maintenance</a:t>
             </a:r>
             <a:endParaRPr lang="en-US" sz="700" dirty="0"/>
           </a:p>
@@ -4983,8 +5039,8 @@
         </p:nvSpPr>
         <p:spPr>
           <a:xfrm>
-            <a:off x="457200" y="6510528"/>
-            <a:ext cx="6949440" cy="228600"/>
+            <a:off x="457200" y="6400800"/>
+            <a:ext cx="6949440" cy="201168"/>
           </a:xfrm>
           <a:prstGeom prst="rect">
             <a:avLst/>
@@ -5022,8 +5078,8 @@
         </p:nvSpPr>
         <p:spPr>
           <a:xfrm>
-            <a:off x="7589520" y="6510528"/>
-            <a:ext cx="4144975" cy="228600"/>
+            <a:off x="7589520" y="6400800"/>
+            <a:ext cx="4144975" cy="201168"/>
           </a:xfrm>
           <a:prstGeom prst="rect">
             <a:avLst/>
@@ -5104,7 +5160,7 @@
     </a:clrScheme>
     <a:fontScheme name="Office">
       <a:majorFont>
-        <a:latin typeface="Calibri Light" panose="020F0302020204030204"/>
+        <a:latin typeface="Arial"/>
         <a:ea typeface=""/>
         <a:cs typeface=""/>
         <a:font script="Jpan" typeface="游ゴシック Light"/>
@@ -5156,7 +5212,7 @@
         <a:font script="Tfng" typeface="Ebrima"/>
       </a:majorFont>
       <a:minorFont>
-        <a:latin typeface="Calibri" panose="020F0502020204030204"/>
+        <a:latin typeface="Arial"/>
         <a:ea typeface=""/>
         <a:cs typeface=""/>
         <a:font script="Jpan" typeface="游ゴシック"/>

</xml_diff>